<commit_message>
Add indie tab to SocialBuzz in IntelHub + indie filter in BriefList
</commit_message>
<xml_diff>
--- a/maof-pitch-deck.pptx
+++ b/maof-pitch-deck.pptx
@@ -3258,7 +3258,7 @@
           </a:bodyPr>
           <a:lstStyle/>
           <a:p>
-            <a:pPr algn="r"/>
+            <a:pPr algn="r" a:rtl="1"/>
             <a:r>
               <a:rPr sz="7200" b="1">
                 <a:solidFill>
@@ -3293,7 +3293,7 @@
           </a:bodyPr>
           <a:lstStyle/>
           <a:p>
-            <a:pPr algn="r"/>
+            <a:pPr algn="r" a:rtl="1"/>
             <a:r>
               <a:rPr sz="3600" b="1">
                 <a:solidFill>
@@ -3328,7 +3328,7 @@
           </a:bodyPr>
           <a:lstStyle/>
           <a:p>
-            <a:pPr algn="r">
+            <a:pPr algn="r" a:rtl="1">
               <a:spcAft>
                 <a:spcPts val="560"/>
               </a:spcAft>
@@ -3344,7 +3344,7 @@
             </a:r>
           </a:p>
           <a:p>
-            <a:pPr algn="r">
+            <a:pPr algn="r" a:rtl="1">
               <a:spcAft>
                 <a:spcPts val="560"/>
               </a:spcAft>
@@ -3383,7 +3383,7 @@
           </a:bodyPr>
           <a:lstStyle/>
           <a:p>
-            <a:pPr algn="r"/>
+            <a:pPr algn="r" a:rtl="1"/>
             <a:r>
               <a:rPr sz="1400" b="0">
                 <a:solidFill>
@@ -3444,7 +3444,7 @@
           </a:bodyPr>
           <a:lstStyle/>
           <a:p>
-            <a:pPr algn="r"/>
+            <a:pPr algn="r" a:rtl="1"/>
             <a:r>
               <a:rPr sz="3600" b="1">
                 <a:solidFill>
@@ -3608,7 +3608,7 @@
           </a:bodyPr>
           <a:lstStyle/>
           <a:p>
-            <a:pPr algn="ctr"/>
+            <a:pPr algn="ctr" a:rtl="1"/>
             <a:r>
               <a:rPr sz="1400" b="1">
                 <a:solidFill>
@@ -3643,7 +3643,7 @@
           </a:bodyPr>
           <a:lstStyle/>
           <a:p>
-            <a:pPr algn="ctr"/>
+            <a:pPr algn="ctr" a:rtl="1"/>
             <a:r>
               <a:rPr sz="1400" b="1">
                 <a:solidFill>
@@ -3678,7 +3678,7 @@
           </a:bodyPr>
           <a:lstStyle/>
           <a:p>
-            <a:pPr algn="r"/>
+            <a:pPr algn="r" a:rtl="1"/>
             <a:r>
               <a:rPr sz="1200" b="0">
                 <a:solidFill>
@@ -3713,7 +3713,7 @@
           </a:bodyPr>
           <a:lstStyle/>
           <a:p>
-            <a:pPr algn="r"/>
+            <a:pPr algn="r" a:rtl="1"/>
             <a:r>
               <a:rPr sz="1200" b="0">
                 <a:solidFill>
@@ -3748,7 +3748,7 @@
           </a:bodyPr>
           <a:lstStyle/>
           <a:p>
-            <a:pPr algn="r"/>
+            <a:pPr algn="r" a:rtl="1"/>
             <a:r>
               <a:rPr sz="1200" b="0">
                 <a:solidFill>
@@ -3783,7 +3783,7 @@
           </a:bodyPr>
           <a:lstStyle/>
           <a:p>
-            <a:pPr algn="r"/>
+            <a:pPr algn="r" a:rtl="1"/>
             <a:r>
               <a:rPr sz="1200" b="0">
                 <a:solidFill>
@@ -3947,7 +3947,7 @@
           </a:bodyPr>
           <a:lstStyle/>
           <a:p>
-            <a:pPr algn="ctr"/>
+            <a:pPr algn="ctr" a:rtl="1"/>
             <a:r>
               <a:rPr sz="1400" b="1">
                 <a:solidFill>
@@ -3982,7 +3982,7 @@
           </a:bodyPr>
           <a:lstStyle/>
           <a:p>
-            <a:pPr algn="ctr"/>
+            <a:pPr algn="ctr" a:rtl="1"/>
             <a:r>
               <a:rPr sz="1400" b="1">
                 <a:solidFill>
@@ -4017,7 +4017,7 @@
           </a:bodyPr>
           <a:lstStyle/>
           <a:p>
-            <a:pPr algn="r"/>
+            <a:pPr algn="r" a:rtl="1"/>
             <a:r>
               <a:rPr sz="1200" b="0">
                 <a:solidFill>
@@ -4052,7 +4052,7 @@
           </a:bodyPr>
           <a:lstStyle/>
           <a:p>
-            <a:pPr algn="r"/>
+            <a:pPr algn="r" a:rtl="1"/>
             <a:r>
               <a:rPr sz="1200" b="0">
                 <a:solidFill>
@@ -4087,7 +4087,7 @@
           </a:bodyPr>
           <a:lstStyle/>
           <a:p>
-            <a:pPr algn="r"/>
+            <a:pPr algn="r" a:rtl="1"/>
             <a:r>
               <a:rPr sz="1200" b="0">
                 <a:solidFill>
@@ -4122,7 +4122,7 @@
           </a:bodyPr>
           <a:lstStyle/>
           <a:p>
-            <a:pPr algn="r"/>
+            <a:pPr algn="r" a:rtl="1"/>
             <a:r>
               <a:rPr sz="1200" b="0">
                 <a:solidFill>
@@ -4286,7 +4286,7 @@
           </a:bodyPr>
           <a:lstStyle/>
           <a:p>
-            <a:pPr algn="ctr"/>
+            <a:pPr algn="ctr" a:rtl="1"/>
             <a:r>
               <a:rPr sz="1400" b="1">
                 <a:solidFill>
@@ -4321,7 +4321,7 @@
           </a:bodyPr>
           <a:lstStyle/>
           <a:p>
-            <a:pPr algn="ctr"/>
+            <a:pPr algn="ctr" a:rtl="1"/>
             <a:r>
               <a:rPr sz="1400" b="1">
                 <a:solidFill>
@@ -4356,7 +4356,7 @@
           </a:bodyPr>
           <a:lstStyle/>
           <a:p>
-            <a:pPr algn="r"/>
+            <a:pPr algn="r" a:rtl="1"/>
             <a:r>
               <a:rPr sz="1200" b="0">
                 <a:solidFill>
@@ -4391,7 +4391,7 @@
           </a:bodyPr>
           <a:lstStyle/>
           <a:p>
-            <a:pPr algn="r"/>
+            <a:pPr algn="r" a:rtl="1"/>
             <a:r>
               <a:rPr sz="1200" b="0">
                 <a:solidFill>
@@ -4426,7 +4426,7 @@
           </a:bodyPr>
           <a:lstStyle/>
           <a:p>
-            <a:pPr algn="r"/>
+            <a:pPr algn="r" a:rtl="1"/>
             <a:r>
               <a:rPr sz="1200" b="0">
                 <a:solidFill>
@@ -4461,7 +4461,7 @@
           </a:bodyPr>
           <a:lstStyle/>
           <a:p>
-            <a:pPr algn="r"/>
+            <a:pPr algn="r" a:rtl="1"/>
             <a:r>
               <a:rPr sz="1200" b="0">
                 <a:solidFill>
@@ -4625,7 +4625,7 @@
           </a:bodyPr>
           <a:lstStyle/>
           <a:p>
-            <a:pPr algn="ctr"/>
+            <a:pPr algn="ctr" a:rtl="1"/>
             <a:r>
               <a:rPr sz="1400" b="1">
                 <a:solidFill>
@@ -4660,7 +4660,7 @@
           </a:bodyPr>
           <a:lstStyle/>
           <a:p>
-            <a:pPr algn="ctr"/>
+            <a:pPr algn="ctr" a:rtl="1"/>
             <a:r>
               <a:rPr sz="1400" b="1">
                 <a:solidFill>
@@ -4695,7 +4695,7 @@
           </a:bodyPr>
           <a:lstStyle/>
           <a:p>
-            <a:pPr algn="r"/>
+            <a:pPr algn="r" a:rtl="1"/>
             <a:r>
               <a:rPr sz="1200" b="0">
                 <a:solidFill>
@@ -4730,7 +4730,7 @@
           </a:bodyPr>
           <a:lstStyle/>
           <a:p>
-            <a:pPr algn="r"/>
+            <a:pPr algn="r" a:rtl="1"/>
             <a:r>
               <a:rPr sz="1200" b="0">
                 <a:solidFill>
@@ -4765,7 +4765,7 @@
           </a:bodyPr>
           <a:lstStyle/>
           <a:p>
-            <a:pPr algn="r"/>
+            <a:pPr algn="r" a:rtl="1"/>
             <a:r>
               <a:rPr sz="1200" b="0">
                 <a:solidFill>
@@ -4800,7 +4800,7 @@
           </a:bodyPr>
           <a:lstStyle/>
           <a:p>
-            <a:pPr algn="r"/>
+            <a:pPr algn="r" a:rtl="1"/>
             <a:r>
               <a:rPr sz="1200" b="0">
                 <a:solidFill>
@@ -5119,7 +5119,7 @@
           </a:bodyPr>
           <a:lstStyle/>
           <a:p>
-            <a:pPr algn="r"/>
+            <a:pPr algn="r" a:rtl="1"/>
             <a:r>
               <a:rPr sz="3600" b="1">
                 <a:solidFill>
@@ -5283,7 +5283,7 @@
           </a:bodyPr>
           <a:lstStyle/>
           <a:p>
-            <a:pPr algn="ctr"/>
+            <a:pPr algn="ctr" a:rtl="1"/>
             <a:r>
               <a:rPr sz="3200" b="0">
                 <a:solidFill>
@@ -5318,7 +5318,7 @@
           </a:bodyPr>
           <a:lstStyle/>
           <a:p>
-            <a:pPr algn="ctr"/>
+            <a:pPr algn="ctr" a:rtl="1"/>
             <a:r>
               <a:rPr sz="2000" b="1">
                 <a:solidFill>
@@ -5353,7 +5353,7 @@
           </a:bodyPr>
           <a:lstStyle/>
           <a:p>
-            <a:pPr algn="ctr"/>
+            <a:pPr algn="ctr" a:rtl="1"/>
             <a:r>
               <a:rPr sz="1400" b="0">
                 <a:solidFill>
@@ -5388,7 +5388,7 @@
           </a:bodyPr>
           <a:lstStyle/>
           <a:p>
-            <a:pPr algn="ctr"/>
+            <a:pPr algn="ctr" a:rtl="1"/>
             <a:r>
               <a:rPr sz="1400" b="0">
                 <a:solidFill>
@@ -5423,7 +5423,7 @@
           </a:bodyPr>
           <a:lstStyle/>
           <a:p>
-            <a:pPr algn="ctr"/>
+            <a:pPr algn="ctr" a:rtl="1"/>
             <a:r>
               <a:rPr sz="1400" b="0">
                 <a:solidFill>
@@ -5587,7 +5587,7 @@
           </a:bodyPr>
           <a:lstStyle/>
           <a:p>
-            <a:pPr algn="ctr"/>
+            <a:pPr algn="ctr" a:rtl="1"/>
             <a:r>
               <a:rPr sz="3200" b="0">
                 <a:solidFill>
@@ -5622,7 +5622,7 @@
           </a:bodyPr>
           <a:lstStyle/>
           <a:p>
-            <a:pPr algn="ctr"/>
+            <a:pPr algn="ctr" a:rtl="1"/>
             <a:r>
               <a:rPr sz="2000" b="1">
                 <a:solidFill>
@@ -5657,7 +5657,7 @@
           </a:bodyPr>
           <a:lstStyle/>
           <a:p>
-            <a:pPr algn="ctr"/>
+            <a:pPr algn="ctr" a:rtl="1"/>
             <a:r>
               <a:rPr sz="1400" b="0">
                 <a:solidFill>
@@ -5692,7 +5692,7 @@
           </a:bodyPr>
           <a:lstStyle/>
           <a:p>
-            <a:pPr algn="ctr"/>
+            <a:pPr algn="ctr" a:rtl="1"/>
             <a:r>
               <a:rPr sz="1400" b="0">
                 <a:solidFill>
@@ -5727,7 +5727,7 @@
           </a:bodyPr>
           <a:lstStyle/>
           <a:p>
-            <a:pPr algn="ctr"/>
+            <a:pPr algn="ctr" a:rtl="1"/>
             <a:r>
               <a:rPr sz="1400" b="0">
                 <a:solidFill>
@@ -5874,7 +5874,7 @@
           </a:bodyPr>
           <a:lstStyle/>
           <a:p>
-            <a:pPr algn="ctr"/>
+            <a:pPr algn="ctr" a:rtl="1"/>
             <a:r>
               <a:rPr sz="6000" b="1">
                 <a:solidFill>
@@ -5909,7 +5909,7 @@
           </a:bodyPr>
           <a:lstStyle/>
           <a:p>
-            <a:pPr algn="ctr"/>
+            <a:pPr algn="ctr" a:rtl="1"/>
             <a:r>
               <a:rPr sz="2800" b="0">
                 <a:solidFill>
@@ -5987,7 +5987,7 @@
           </a:bodyPr>
           <a:lstStyle/>
           <a:p>
-            <a:pPr algn="ctr">
+            <a:pPr algn="ctr" a:rtl="1">
               <a:spcAft>
                 <a:spcPts val="560"/>
               </a:spcAft>
@@ -6003,7 +6003,7 @@
             </a:r>
           </a:p>
           <a:p>
-            <a:pPr algn="ctr">
+            <a:pPr algn="ctr" a:rtl="1">
               <a:spcAft>
                 <a:spcPts val="560"/>
               </a:spcAft>
@@ -6019,7 +6019,7 @@
             </a:r>
           </a:p>
           <a:p>
-            <a:pPr algn="ctr">
+            <a:pPr algn="ctr" a:rtl="1">
               <a:spcAft>
                 <a:spcPts val="560"/>
               </a:spcAft>
@@ -6101,7 +6101,7 @@
           </a:bodyPr>
           <a:lstStyle/>
           <a:p>
-            <a:pPr algn="ctr"/>
+            <a:pPr algn="ctr" a:rtl="1"/>
             <a:r>
               <a:rPr sz="1600" b="1">
                 <a:solidFill>
@@ -6179,7 +6179,7 @@
           </a:bodyPr>
           <a:lstStyle/>
           <a:p>
-            <a:pPr algn="ctr"/>
+            <a:pPr algn="ctr" a:rtl="1"/>
             <a:r>
               <a:rPr sz="1600" b="1">
                 <a:solidFill>
@@ -6257,7 +6257,7 @@
           </a:bodyPr>
           <a:lstStyle/>
           <a:p>
-            <a:pPr algn="ctr"/>
+            <a:pPr algn="ctr" a:rtl="1"/>
             <a:r>
               <a:rPr sz="1600" b="1">
                 <a:solidFill>
@@ -6292,7 +6292,7 @@
           </a:bodyPr>
           <a:lstStyle/>
           <a:p>
-            <a:pPr algn="ctr"/>
+            <a:pPr algn="ctr" a:rtl="1"/>
             <a:r>
               <a:rPr sz="1200" b="0">
                 <a:solidFill>
@@ -6353,7 +6353,7 @@
           </a:bodyPr>
           <a:lstStyle/>
           <a:p>
-            <a:pPr algn="r"/>
+            <a:pPr algn="r" a:rtl="1"/>
             <a:r>
               <a:rPr sz="3600" b="1">
                 <a:solidFill>
@@ -6474,7 +6474,7 @@
           </a:bodyPr>
           <a:lstStyle/>
           <a:p>
-            <a:pPr algn="r"/>
+            <a:pPr algn="r" a:rtl="1"/>
             <a:r>
               <a:rPr sz="2400" b="1">
                 <a:solidFill>
@@ -6509,7 +6509,7 @@
           </a:bodyPr>
           <a:lstStyle/>
           <a:p>
-            <a:pPr algn="r">
+            <a:pPr algn="r" a:rtl="1">
               <a:spcAft>
                 <a:spcPts val="560"/>
               </a:spcAft>
@@ -6525,7 +6525,7 @@
             </a:r>
           </a:p>
           <a:p>
-            <a:pPr algn="r">
+            <a:pPr algn="r" a:rtl="1">
               <a:spcAft>
                 <a:spcPts val="560"/>
               </a:spcAft>
@@ -6541,7 +6541,7 @@
             </a:r>
           </a:p>
           <a:p>
-            <a:pPr algn="r">
+            <a:pPr algn="r" a:rtl="1">
               <a:spcAft>
                 <a:spcPts val="560"/>
               </a:spcAft>
@@ -6557,7 +6557,7 @@
             </a:r>
           </a:p>
           <a:p>
-            <a:pPr algn="r">
+            <a:pPr algn="r" a:rtl="1">
               <a:spcAft>
                 <a:spcPts val="560"/>
               </a:spcAft>
@@ -6573,7 +6573,7 @@
             </a:r>
           </a:p>
           <a:p>
-            <a:pPr algn="r">
+            <a:pPr algn="r" a:rtl="1">
               <a:spcAft>
                 <a:spcPts val="560"/>
               </a:spcAft>
@@ -6589,7 +6589,7 @@
             </a:r>
           </a:p>
           <a:p>
-            <a:pPr algn="r">
+            <a:pPr algn="r" a:rtl="1">
               <a:spcAft>
                 <a:spcPts val="560"/>
               </a:spcAft>
@@ -6714,7 +6714,7 @@
           </a:bodyPr>
           <a:lstStyle/>
           <a:p>
-            <a:pPr algn="r"/>
+            <a:pPr algn="r" a:rtl="1"/>
             <a:r>
               <a:rPr sz="2400" b="1">
                 <a:solidFill>
@@ -6749,7 +6749,7 @@
           </a:bodyPr>
           <a:lstStyle/>
           <a:p>
-            <a:pPr algn="r">
+            <a:pPr algn="r" a:rtl="1">
               <a:spcAft>
                 <a:spcPts val="560"/>
               </a:spcAft>
@@ -6765,7 +6765,7 @@
             </a:r>
           </a:p>
           <a:p>
-            <a:pPr algn="r">
+            <a:pPr algn="r" a:rtl="1">
               <a:spcAft>
                 <a:spcPts val="560"/>
               </a:spcAft>
@@ -6781,7 +6781,7 @@
             </a:r>
           </a:p>
           <a:p>
-            <a:pPr algn="r">
+            <a:pPr algn="r" a:rtl="1">
               <a:spcAft>
                 <a:spcPts val="560"/>
               </a:spcAft>
@@ -6797,7 +6797,7 @@
             </a:r>
           </a:p>
           <a:p>
-            <a:pPr algn="r">
+            <a:pPr algn="r" a:rtl="1">
               <a:spcAft>
                 <a:spcPts val="560"/>
               </a:spcAft>
@@ -6813,7 +6813,7 @@
             </a:r>
           </a:p>
           <a:p>
-            <a:pPr algn="r">
+            <a:pPr algn="r" a:rtl="1">
               <a:spcAft>
                 <a:spcPts val="560"/>
               </a:spcAft>
@@ -6829,7 +6829,7 @@
             </a:r>
           </a:p>
           <a:p>
-            <a:pPr algn="r">
+            <a:pPr algn="r" a:rtl="1">
               <a:spcAft>
                 <a:spcPts val="560"/>
               </a:spcAft>
@@ -6937,7 +6937,7 @@
           </a:bodyPr>
           <a:lstStyle/>
           <a:p>
-            <a:pPr algn="r"/>
+            <a:pPr algn="r" a:rtl="1"/>
             <a:r>
               <a:rPr sz="3200" b="1">
                 <a:solidFill>
@@ -6972,7 +6972,7 @@
           </a:bodyPr>
           <a:lstStyle/>
           <a:p>
-            <a:pPr algn="r"/>
+            <a:pPr algn="r" a:rtl="1"/>
             <a:r>
               <a:rPr sz="1800" b="0">
                 <a:solidFill>
@@ -7136,7 +7136,7 @@
           </a:bodyPr>
           <a:lstStyle/>
           <a:p>
-            <a:pPr algn="ctr"/>
+            <a:pPr algn="ctr" a:rtl="1"/>
             <a:r>
               <a:rPr sz="2800" b="0">
                 <a:solidFill>
@@ -7171,7 +7171,7 @@
           </a:bodyPr>
           <a:lstStyle/>
           <a:p>
-            <a:pPr algn="ctr"/>
+            <a:pPr algn="ctr" a:rtl="1"/>
             <a:r>
               <a:rPr sz="1600" b="1">
                 <a:solidFill>
@@ -7206,7 +7206,7 @@
           </a:bodyPr>
           <a:lstStyle/>
           <a:p>
-            <a:pPr algn="ctr"/>
+            <a:pPr algn="ctr" a:rtl="1"/>
             <a:r>
               <a:rPr sz="1200" b="0">
                 <a:solidFill>
@@ -7241,7 +7241,7 @@
           </a:bodyPr>
           <a:lstStyle/>
           <a:p>
-            <a:pPr algn="ctr"/>
+            <a:pPr algn="ctr" a:rtl="1"/>
             <a:r>
               <a:rPr sz="1200" b="0">
                 <a:solidFill>
@@ -7405,7 +7405,7 @@
           </a:bodyPr>
           <a:lstStyle/>
           <a:p>
-            <a:pPr algn="ctr"/>
+            <a:pPr algn="ctr" a:rtl="1"/>
             <a:r>
               <a:rPr sz="2800" b="0">
                 <a:solidFill>
@@ -7440,7 +7440,7 @@
           </a:bodyPr>
           <a:lstStyle/>
           <a:p>
-            <a:pPr algn="ctr"/>
+            <a:pPr algn="ctr" a:rtl="1"/>
             <a:r>
               <a:rPr sz="1600" b="1">
                 <a:solidFill>
@@ -7475,7 +7475,7 @@
           </a:bodyPr>
           <a:lstStyle/>
           <a:p>
-            <a:pPr algn="ctr"/>
+            <a:pPr algn="ctr" a:rtl="1"/>
             <a:r>
               <a:rPr sz="1200" b="0">
                 <a:solidFill>
@@ -7510,7 +7510,7 @@
           </a:bodyPr>
           <a:lstStyle/>
           <a:p>
-            <a:pPr algn="ctr"/>
+            <a:pPr algn="ctr" a:rtl="1"/>
             <a:r>
               <a:rPr sz="1200" b="0">
                 <a:solidFill>
@@ -7674,7 +7674,7 @@
           </a:bodyPr>
           <a:lstStyle/>
           <a:p>
-            <a:pPr algn="ctr"/>
+            <a:pPr algn="ctr" a:rtl="1"/>
             <a:r>
               <a:rPr sz="2800" b="0">
                 <a:solidFill>
@@ -7709,7 +7709,7 @@
           </a:bodyPr>
           <a:lstStyle/>
           <a:p>
-            <a:pPr algn="ctr"/>
+            <a:pPr algn="ctr" a:rtl="1"/>
             <a:r>
               <a:rPr sz="1600" b="1">
                 <a:solidFill>
@@ -7744,7 +7744,7 @@
           </a:bodyPr>
           <a:lstStyle/>
           <a:p>
-            <a:pPr algn="ctr"/>
+            <a:pPr algn="ctr" a:rtl="1"/>
             <a:r>
               <a:rPr sz="1200" b="0">
                 <a:solidFill>
@@ -7779,7 +7779,7 @@
           </a:bodyPr>
           <a:lstStyle/>
           <a:p>
-            <a:pPr algn="ctr"/>
+            <a:pPr algn="ctr" a:rtl="1"/>
             <a:r>
               <a:rPr sz="1200" b="0">
                 <a:solidFill>
@@ -7943,7 +7943,7 @@
           </a:bodyPr>
           <a:lstStyle/>
           <a:p>
-            <a:pPr algn="ctr"/>
+            <a:pPr algn="ctr" a:rtl="1"/>
             <a:r>
               <a:rPr sz="2800" b="0">
                 <a:solidFill>
@@ -7978,7 +7978,7 @@
           </a:bodyPr>
           <a:lstStyle/>
           <a:p>
-            <a:pPr algn="ctr"/>
+            <a:pPr algn="ctr" a:rtl="1"/>
             <a:r>
               <a:rPr sz="1600" b="1">
                 <a:solidFill>
@@ -8013,7 +8013,7 @@
           </a:bodyPr>
           <a:lstStyle/>
           <a:p>
-            <a:pPr algn="ctr"/>
+            <a:pPr algn="ctr" a:rtl="1"/>
             <a:r>
               <a:rPr sz="1200" b="0">
                 <a:solidFill>
@@ -8048,7 +8048,7 @@
           </a:bodyPr>
           <a:lstStyle/>
           <a:p>
-            <a:pPr algn="ctr"/>
+            <a:pPr algn="ctr" a:rtl="1"/>
             <a:r>
               <a:rPr sz="1200" b="0">
                 <a:solidFill>
@@ -8212,7 +8212,7 @@
           </a:bodyPr>
           <a:lstStyle/>
           <a:p>
-            <a:pPr algn="ctr"/>
+            <a:pPr algn="ctr" a:rtl="1"/>
             <a:r>
               <a:rPr sz="2800" b="0">
                 <a:solidFill>
@@ -8247,7 +8247,7 @@
           </a:bodyPr>
           <a:lstStyle/>
           <a:p>
-            <a:pPr algn="ctr"/>
+            <a:pPr algn="ctr" a:rtl="1"/>
             <a:r>
               <a:rPr sz="1600" b="1">
                 <a:solidFill>
@@ -8282,7 +8282,7 @@
           </a:bodyPr>
           <a:lstStyle/>
           <a:p>
-            <a:pPr algn="ctr"/>
+            <a:pPr algn="ctr" a:rtl="1"/>
             <a:r>
               <a:rPr sz="1200" b="0">
                 <a:solidFill>
@@ -8317,7 +8317,7 @@
           </a:bodyPr>
           <a:lstStyle/>
           <a:p>
-            <a:pPr algn="ctr"/>
+            <a:pPr algn="ctr" a:rtl="1"/>
             <a:r>
               <a:rPr sz="1200" b="0">
                 <a:solidFill>
@@ -8352,7 +8352,7 @@
           </a:bodyPr>
           <a:lstStyle/>
           <a:p>
-            <a:pPr algn="ctr"/>
+            <a:pPr algn="ctr" a:rtl="1"/>
             <a:r>
               <a:rPr sz="1600" b="0">
                 <a:solidFill>
@@ -8413,7 +8413,7 @@
           </a:bodyPr>
           <a:lstStyle/>
           <a:p>
-            <a:pPr algn="r"/>
+            <a:pPr algn="r" a:rtl="1"/>
             <a:r>
               <a:rPr sz="3600" b="1">
                 <a:solidFill>
@@ -8448,7 +8448,7 @@
           </a:bodyPr>
           <a:lstStyle/>
           <a:p>
-            <a:pPr algn="r"/>
+            <a:pPr algn="r" a:rtl="1"/>
             <a:r>
               <a:rPr sz="1800" b="1">
                 <a:solidFill>
@@ -8612,7 +8612,7 @@
           </a:bodyPr>
           <a:lstStyle/>
           <a:p>
-            <a:pPr algn="ctr"/>
+            <a:pPr algn="ctr" a:rtl="1"/>
             <a:r>
               <a:rPr sz="2400" b="1">
                 <a:solidFill>
@@ -8647,7 +8647,7 @@
           </a:bodyPr>
           <a:lstStyle/>
           <a:p>
-            <a:pPr algn="ctr"/>
+            <a:pPr algn="ctr" a:rtl="1"/>
             <a:r>
               <a:rPr sz="1600" b="1">
                 <a:solidFill>
@@ -8682,7 +8682,7 @@
           </a:bodyPr>
           <a:lstStyle/>
           <a:p>
-            <a:pPr algn="ctr"/>
+            <a:pPr algn="ctr" a:rtl="1"/>
             <a:r>
               <a:rPr sz="1300" b="1">
                 <a:solidFill>
@@ -8717,7 +8717,7 @@
           </a:bodyPr>
           <a:lstStyle/>
           <a:p>
-            <a:pPr algn="ctr"/>
+            <a:pPr algn="ctr" a:rtl="1"/>
             <a:r>
               <a:rPr sz="1200" b="0">
                 <a:solidFill>
@@ -8752,7 +8752,7 @@
           </a:bodyPr>
           <a:lstStyle/>
           <a:p>
-            <a:pPr algn="ctr"/>
+            <a:pPr algn="ctr" a:rtl="1"/>
             <a:r>
               <a:rPr sz="1200" b="0">
                 <a:solidFill>
@@ -8787,7 +8787,7 @@
           </a:bodyPr>
           <a:lstStyle/>
           <a:p>
-            <a:pPr algn="ctr"/>
+            <a:pPr algn="ctr" a:rtl="1"/>
             <a:r>
               <a:rPr sz="1200" b="0">
                 <a:solidFill>
@@ -8951,7 +8951,7 @@
           </a:bodyPr>
           <a:lstStyle/>
           <a:p>
-            <a:pPr algn="ctr"/>
+            <a:pPr algn="ctr" a:rtl="1"/>
             <a:r>
               <a:rPr sz="2400" b="1">
                 <a:solidFill>
@@ -8986,7 +8986,7 @@
           </a:bodyPr>
           <a:lstStyle/>
           <a:p>
-            <a:pPr algn="ctr"/>
+            <a:pPr algn="ctr" a:rtl="1"/>
             <a:r>
               <a:rPr sz="1600" b="1">
                 <a:solidFill>
@@ -9021,7 +9021,7 @@
           </a:bodyPr>
           <a:lstStyle/>
           <a:p>
-            <a:pPr algn="ctr"/>
+            <a:pPr algn="ctr" a:rtl="1"/>
             <a:r>
               <a:rPr sz="1300" b="1">
                 <a:solidFill>
@@ -9056,7 +9056,7 @@
           </a:bodyPr>
           <a:lstStyle/>
           <a:p>
-            <a:pPr algn="ctr"/>
+            <a:pPr algn="ctr" a:rtl="1"/>
             <a:r>
               <a:rPr sz="1200" b="0">
                 <a:solidFill>
@@ -9091,7 +9091,7 @@
           </a:bodyPr>
           <a:lstStyle/>
           <a:p>
-            <a:pPr algn="ctr"/>
+            <a:pPr algn="ctr" a:rtl="1"/>
             <a:r>
               <a:rPr sz="1200" b="0">
                 <a:solidFill>
@@ -9126,7 +9126,7 @@
           </a:bodyPr>
           <a:lstStyle/>
           <a:p>
-            <a:pPr algn="ctr"/>
+            <a:pPr algn="ctr" a:rtl="1"/>
             <a:r>
               <a:rPr sz="1200" b="0">
                 <a:solidFill>
@@ -9290,7 +9290,7 @@
           </a:bodyPr>
           <a:lstStyle/>
           <a:p>
-            <a:pPr algn="ctr"/>
+            <a:pPr algn="ctr" a:rtl="1"/>
             <a:r>
               <a:rPr sz="2400" b="1">
                 <a:solidFill>
@@ -9325,7 +9325,7 @@
           </a:bodyPr>
           <a:lstStyle/>
           <a:p>
-            <a:pPr algn="ctr"/>
+            <a:pPr algn="ctr" a:rtl="1"/>
             <a:r>
               <a:rPr sz="1600" b="1">
                 <a:solidFill>
@@ -9360,7 +9360,7 @@
           </a:bodyPr>
           <a:lstStyle/>
           <a:p>
-            <a:pPr algn="ctr"/>
+            <a:pPr algn="ctr" a:rtl="1"/>
             <a:r>
               <a:rPr sz="1300" b="1">
                 <a:solidFill>
@@ -9395,7 +9395,7 @@
           </a:bodyPr>
           <a:lstStyle/>
           <a:p>
-            <a:pPr algn="ctr"/>
+            <a:pPr algn="ctr" a:rtl="1"/>
             <a:r>
               <a:rPr sz="1200" b="0">
                 <a:solidFill>
@@ -9430,7 +9430,7 @@
           </a:bodyPr>
           <a:lstStyle/>
           <a:p>
-            <a:pPr algn="ctr"/>
+            <a:pPr algn="ctr" a:rtl="1"/>
             <a:r>
               <a:rPr sz="1200" b="0">
                 <a:solidFill>
@@ -9465,7 +9465,7 @@
           </a:bodyPr>
           <a:lstStyle/>
           <a:p>
-            <a:pPr algn="ctr"/>
+            <a:pPr algn="ctr" a:rtl="1"/>
             <a:r>
               <a:rPr sz="1200" b="0">
                 <a:solidFill>
@@ -9629,7 +9629,7 @@
           </a:bodyPr>
           <a:lstStyle/>
           <a:p>
-            <a:pPr algn="ctr"/>
+            <a:pPr algn="ctr" a:rtl="1"/>
             <a:r>
               <a:rPr sz="2400" b="1">
                 <a:solidFill>
@@ -9664,7 +9664,7 @@
           </a:bodyPr>
           <a:lstStyle/>
           <a:p>
-            <a:pPr algn="ctr"/>
+            <a:pPr algn="ctr" a:rtl="1"/>
             <a:r>
               <a:rPr sz="1600" b="1">
                 <a:solidFill>
@@ -9699,7 +9699,7 @@
           </a:bodyPr>
           <a:lstStyle/>
           <a:p>
-            <a:pPr algn="ctr"/>
+            <a:pPr algn="ctr" a:rtl="1"/>
             <a:r>
               <a:rPr sz="1300" b="1">
                 <a:solidFill>
@@ -9734,7 +9734,7 @@
           </a:bodyPr>
           <a:lstStyle/>
           <a:p>
-            <a:pPr algn="ctr"/>
+            <a:pPr algn="ctr" a:rtl="1"/>
             <a:r>
               <a:rPr sz="1200" b="0">
                 <a:solidFill>
@@ -9769,7 +9769,7 @@
           </a:bodyPr>
           <a:lstStyle/>
           <a:p>
-            <a:pPr algn="ctr"/>
+            <a:pPr algn="ctr" a:rtl="1"/>
             <a:r>
               <a:rPr sz="1200" b="0">
                 <a:solidFill>
@@ -9804,7 +9804,7 @@
           </a:bodyPr>
           <a:lstStyle/>
           <a:p>
-            <a:pPr algn="ctr"/>
+            <a:pPr algn="ctr" a:rtl="1"/>
             <a:r>
               <a:rPr sz="1200" b="0">
                 <a:solidFill>
@@ -9839,7 +9839,7 @@
           </a:bodyPr>
           <a:lstStyle/>
           <a:p>
-            <a:pPr algn="ctr"/>
+            <a:pPr algn="ctr" a:rtl="1"/>
             <a:r>
               <a:rPr sz="2400" b="1">
                 <a:solidFill>
@@ -9874,7 +9874,7 @@
           </a:bodyPr>
           <a:lstStyle/>
           <a:p>
-            <a:pPr algn="ctr"/>
+            <a:pPr algn="ctr" a:rtl="1"/>
             <a:r>
               <a:rPr sz="2400" b="1">
                 <a:solidFill>
@@ -9909,7 +9909,7 @@
           </a:bodyPr>
           <a:lstStyle/>
           <a:p>
-            <a:pPr algn="ctr"/>
+            <a:pPr algn="ctr" a:rtl="1"/>
             <a:r>
               <a:rPr sz="2400" b="1">
                 <a:solidFill>
@@ -10013,7 +10013,7 @@
           </a:bodyPr>
           <a:lstStyle/>
           <a:p>
-            <a:pPr algn="r"/>
+            <a:pPr algn="r" a:rtl="1"/>
             <a:r>
               <a:rPr sz="3200" b="1">
                 <a:solidFill>
@@ -10048,7 +10048,7 @@
           </a:bodyPr>
           <a:lstStyle/>
           <a:p>
-            <a:pPr algn="r"/>
+            <a:pPr algn="r" a:rtl="1"/>
             <a:r>
               <a:rPr sz="1600" b="0">
                 <a:solidFill>
@@ -10169,7 +10169,7 @@
           </a:bodyPr>
           <a:lstStyle/>
           <a:p>
-            <a:pPr algn="r"/>
+            <a:pPr algn="r" a:rtl="1"/>
             <a:r>
               <a:rPr sz="2200" b="1">
                 <a:solidFill>
@@ -10204,7 +10204,7 @@
           </a:bodyPr>
           <a:lstStyle/>
           <a:p>
-            <a:pPr algn="r"/>
+            <a:pPr algn="r" a:rtl="1"/>
             <a:r>
               <a:rPr sz="1400" b="0">
                 <a:solidFill>
@@ -10282,7 +10282,7 @@
           </a:bodyPr>
           <a:lstStyle/>
           <a:p>
-            <a:pPr algn="ctr"/>
+            <a:pPr algn="ctr" a:rtl="1"/>
             <a:r>
               <a:rPr sz="1400" b="1">
                 <a:solidFill>
@@ -10317,7 +10317,7 @@
           </a:bodyPr>
           <a:lstStyle/>
           <a:p>
-            <a:pPr algn="r"/>
+            <a:pPr algn="r" a:rtl="1"/>
             <a:r>
               <a:rPr sz="1400" b="1">
                 <a:solidFill>
@@ -10352,7 +10352,7 @@
           </a:bodyPr>
           <a:lstStyle/>
           <a:p>
-            <a:pPr algn="r"/>
+            <a:pPr algn="r" a:rtl="1"/>
             <a:r>
               <a:rPr sz="1100" b="0">
                 <a:solidFill>
@@ -10430,7 +10430,7 @@
           </a:bodyPr>
           <a:lstStyle/>
           <a:p>
-            <a:pPr algn="ctr"/>
+            <a:pPr algn="ctr" a:rtl="1"/>
             <a:r>
               <a:rPr sz="1400" b="1">
                 <a:solidFill>
@@ -10465,7 +10465,7 @@
           </a:bodyPr>
           <a:lstStyle/>
           <a:p>
-            <a:pPr algn="r"/>
+            <a:pPr algn="r" a:rtl="1"/>
             <a:r>
               <a:rPr sz="1400" b="1">
                 <a:solidFill>
@@ -10500,7 +10500,7 @@
           </a:bodyPr>
           <a:lstStyle/>
           <a:p>
-            <a:pPr algn="r"/>
+            <a:pPr algn="r" a:rtl="1"/>
             <a:r>
               <a:rPr sz="1100" b="0">
                 <a:solidFill>
@@ -10578,7 +10578,7 @@
           </a:bodyPr>
           <a:lstStyle/>
           <a:p>
-            <a:pPr algn="ctr"/>
+            <a:pPr algn="ctr" a:rtl="1"/>
             <a:r>
               <a:rPr sz="1400" b="1">
                 <a:solidFill>
@@ -10613,7 +10613,7 @@
           </a:bodyPr>
           <a:lstStyle/>
           <a:p>
-            <a:pPr algn="r"/>
+            <a:pPr algn="r" a:rtl="1"/>
             <a:r>
               <a:rPr sz="1400" b="1">
                 <a:solidFill>
@@ -10648,7 +10648,7 @@
           </a:bodyPr>
           <a:lstStyle/>
           <a:p>
-            <a:pPr algn="r"/>
+            <a:pPr algn="r" a:rtl="1"/>
             <a:r>
               <a:rPr sz="1100" b="0">
                 <a:solidFill>
@@ -10726,7 +10726,7 @@
           </a:bodyPr>
           <a:lstStyle/>
           <a:p>
-            <a:pPr algn="ctr"/>
+            <a:pPr algn="ctr" a:rtl="1"/>
             <a:r>
               <a:rPr sz="1400" b="1">
                 <a:solidFill>
@@ -10761,7 +10761,7 @@
           </a:bodyPr>
           <a:lstStyle/>
           <a:p>
-            <a:pPr algn="r"/>
+            <a:pPr algn="r" a:rtl="1"/>
             <a:r>
               <a:rPr sz="1400" b="1">
                 <a:solidFill>
@@ -10796,7 +10796,7 @@
           </a:bodyPr>
           <a:lstStyle/>
           <a:p>
-            <a:pPr algn="r"/>
+            <a:pPr algn="r" a:rtl="1"/>
             <a:r>
               <a:rPr sz="1100" b="0">
                 <a:solidFill>
@@ -10917,7 +10917,7 @@
           </a:bodyPr>
           <a:lstStyle/>
           <a:p>
-            <a:pPr algn="r"/>
+            <a:pPr algn="r" a:rtl="1"/>
             <a:r>
               <a:rPr sz="2200" b="1">
                 <a:solidFill>
@@ -10952,7 +10952,7 @@
           </a:bodyPr>
           <a:lstStyle/>
           <a:p>
-            <a:pPr algn="r"/>
+            <a:pPr algn="r" a:rtl="1"/>
             <a:r>
               <a:rPr sz="1400" b="0">
                 <a:solidFill>
@@ -11030,7 +11030,7 @@
           </a:bodyPr>
           <a:lstStyle/>
           <a:p>
-            <a:pPr algn="ctr"/>
+            <a:pPr algn="ctr" a:rtl="1"/>
             <a:r>
               <a:rPr sz="1400" b="1">
                 <a:solidFill>
@@ -11065,7 +11065,7 @@
           </a:bodyPr>
           <a:lstStyle/>
           <a:p>
-            <a:pPr algn="r"/>
+            <a:pPr algn="r" a:rtl="1"/>
             <a:r>
               <a:rPr sz="1400" b="1">
                 <a:solidFill>
@@ -11100,7 +11100,7 @@
           </a:bodyPr>
           <a:lstStyle/>
           <a:p>
-            <a:pPr algn="r"/>
+            <a:pPr algn="r" a:rtl="1"/>
             <a:r>
               <a:rPr sz="1100" b="0">
                 <a:solidFill>
@@ -11178,7 +11178,7 @@
           </a:bodyPr>
           <a:lstStyle/>
           <a:p>
-            <a:pPr algn="ctr"/>
+            <a:pPr algn="ctr" a:rtl="1"/>
             <a:r>
               <a:rPr sz="1400" b="1">
                 <a:solidFill>
@@ -11213,7 +11213,7 @@
           </a:bodyPr>
           <a:lstStyle/>
           <a:p>
-            <a:pPr algn="r"/>
+            <a:pPr algn="r" a:rtl="1"/>
             <a:r>
               <a:rPr sz="1400" b="1">
                 <a:solidFill>
@@ -11248,7 +11248,7 @@
           </a:bodyPr>
           <a:lstStyle/>
           <a:p>
-            <a:pPr algn="r"/>
+            <a:pPr algn="r" a:rtl="1"/>
             <a:r>
               <a:rPr sz="1100" b="0">
                 <a:solidFill>
@@ -11326,7 +11326,7 @@
           </a:bodyPr>
           <a:lstStyle/>
           <a:p>
-            <a:pPr algn="ctr"/>
+            <a:pPr algn="ctr" a:rtl="1"/>
             <a:r>
               <a:rPr sz="1400" b="1">
                 <a:solidFill>
@@ -11361,7 +11361,7 @@
           </a:bodyPr>
           <a:lstStyle/>
           <a:p>
-            <a:pPr algn="r"/>
+            <a:pPr algn="r" a:rtl="1"/>
             <a:r>
               <a:rPr sz="1400" b="1">
                 <a:solidFill>
@@ -11396,7 +11396,7 @@
           </a:bodyPr>
           <a:lstStyle/>
           <a:p>
-            <a:pPr algn="r"/>
+            <a:pPr algn="r" a:rtl="1"/>
             <a:r>
               <a:rPr sz="1100" b="0">
                 <a:solidFill>
@@ -11474,7 +11474,7 @@
           </a:bodyPr>
           <a:lstStyle/>
           <a:p>
-            <a:pPr algn="ctr"/>
+            <a:pPr algn="ctr" a:rtl="1"/>
             <a:r>
               <a:rPr sz="1400" b="1">
                 <a:solidFill>
@@ -11509,7 +11509,7 @@
           </a:bodyPr>
           <a:lstStyle/>
           <a:p>
-            <a:pPr algn="r"/>
+            <a:pPr algn="r" a:rtl="1"/>
             <a:r>
               <a:rPr sz="1400" b="1">
                 <a:solidFill>
@@ -11544,7 +11544,7 @@
           </a:bodyPr>
           <a:lstStyle/>
           <a:p>
-            <a:pPr algn="r"/>
+            <a:pPr algn="r" a:rtl="1"/>
             <a:r>
               <a:rPr sz="1100" b="0">
                 <a:solidFill>
@@ -11622,7 +11622,7 @@
           </a:bodyPr>
           <a:lstStyle/>
           <a:p>
-            <a:pPr algn="ctr"/>
+            <a:pPr algn="ctr" a:rtl="1"/>
             <a:r>
               <a:rPr sz="1600" b="1">
                 <a:solidFill>
@@ -11683,7 +11683,7 @@
           </a:bodyPr>
           <a:lstStyle/>
           <a:p>
-            <a:pPr algn="r"/>
+            <a:pPr algn="r" a:rtl="1"/>
             <a:r>
               <a:rPr sz="3600" b="1">
                 <a:solidFill>
@@ -11847,7 +11847,7 @@
           </a:bodyPr>
           <a:lstStyle/>
           <a:p>
-            <a:pPr algn="ctr"/>
+            <a:pPr algn="ctr" a:rtl="1"/>
             <a:r>
               <a:rPr sz="2400" b="0">
                 <a:solidFill>
@@ -11882,7 +11882,7 @@
           </a:bodyPr>
           <a:lstStyle/>
           <a:p>
-            <a:pPr algn="ctr"/>
+            <a:pPr algn="ctr" a:rtl="1"/>
             <a:r>
               <a:rPr sz="1800" b="1">
                 <a:solidFill>
@@ -11917,7 +11917,7 @@
           </a:bodyPr>
           <a:lstStyle/>
           <a:p>
-            <a:pPr algn="r"/>
+            <a:pPr algn="r" a:rtl="1"/>
             <a:r>
               <a:rPr sz="1300" b="0">
                 <a:solidFill>
@@ -11952,7 +11952,7 @@
           </a:bodyPr>
           <a:lstStyle/>
           <a:p>
-            <a:pPr algn="r"/>
+            <a:pPr algn="r" a:rtl="1"/>
             <a:r>
               <a:rPr sz="1300" b="0">
                 <a:solidFill>
@@ -11987,7 +11987,7 @@
           </a:bodyPr>
           <a:lstStyle/>
           <a:p>
-            <a:pPr algn="r"/>
+            <a:pPr algn="r" a:rtl="1"/>
             <a:r>
               <a:rPr sz="1300" b="0">
                 <a:solidFill>
@@ -12022,7 +12022,7 @@
           </a:bodyPr>
           <a:lstStyle/>
           <a:p>
-            <a:pPr algn="r"/>
+            <a:pPr algn="r" a:rtl="1"/>
             <a:r>
               <a:rPr sz="1300" b="0">
                 <a:solidFill>
@@ -12057,7 +12057,7 @@
           </a:bodyPr>
           <a:lstStyle/>
           <a:p>
-            <a:pPr algn="r"/>
+            <a:pPr algn="r" a:rtl="1"/>
             <a:r>
               <a:rPr sz="1300" b="0">
                 <a:solidFill>
@@ -12221,7 +12221,7 @@
           </a:bodyPr>
           <a:lstStyle/>
           <a:p>
-            <a:pPr algn="ctr"/>
+            <a:pPr algn="ctr" a:rtl="1"/>
             <a:r>
               <a:rPr sz="2400" b="0">
                 <a:solidFill>
@@ -12256,7 +12256,7 @@
           </a:bodyPr>
           <a:lstStyle/>
           <a:p>
-            <a:pPr algn="ctr"/>
+            <a:pPr algn="ctr" a:rtl="1"/>
             <a:r>
               <a:rPr sz="1800" b="1">
                 <a:solidFill>
@@ -12291,7 +12291,7 @@
           </a:bodyPr>
           <a:lstStyle/>
           <a:p>
-            <a:pPr algn="r"/>
+            <a:pPr algn="r" a:rtl="1"/>
             <a:r>
               <a:rPr sz="1300" b="0">
                 <a:solidFill>
@@ -12326,7 +12326,7 @@
           </a:bodyPr>
           <a:lstStyle/>
           <a:p>
-            <a:pPr algn="r"/>
+            <a:pPr algn="r" a:rtl="1"/>
             <a:r>
               <a:rPr sz="1300" b="0">
                 <a:solidFill>
@@ -12361,7 +12361,7 @@
           </a:bodyPr>
           <a:lstStyle/>
           <a:p>
-            <a:pPr algn="r"/>
+            <a:pPr algn="r" a:rtl="1"/>
             <a:r>
               <a:rPr sz="1300" b="0">
                 <a:solidFill>
@@ -12396,7 +12396,7 @@
           </a:bodyPr>
           <a:lstStyle/>
           <a:p>
-            <a:pPr algn="r"/>
+            <a:pPr algn="r" a:rtl="1"/>
             <a:r>
               <a:rPr sz="1300" b="0">
                 <a:solidFill>
@@ -12431,7 +12431,7 @@
           </a:bodyPr>
           <a:lstStyle/>
           <a:p>
-            <a:pPr algn="r"/>
+            <a:pPr algn="r" a:rtl="1"/>
             <a:r>
               <a:rPr sz="1300" b="0">
                 <a:solidFill>
@@ -12595,7 +12595,7 @@
           </a:bodyPr>
           <a:lstStyle/>
           <a:p>
-            <a:pPr algn="ctr"/>
+            <a:pPr algn="ctr" a:rtl="1"/>
             <a:r>
               <a:rPr sz="2400" b="0">
                 <a:solidFill>
@@ -12630,7 +12630,7 @@
           </a:bodyPr>
           <a:lstStyle/>
           <a:p>
-            <a:pPr algn="ctr"/>
+            <a:pPr algn="ctr" a:rtl="1"/>
             <a:r>
               <a:rPr sz="1800" b="1">
                 <a:solidFill>
@@ -12665,7 +12665,7 @@
           </a:bodyPr>
           <a:lstStyle/>
           <a:p>
-            <a:pPr algn="r"/>
+            <a:pPr algn="r" a:rtl="1"/>
             <a:r>
               <a:rPr sz="1300" b="0">
                 <a:solidFill>
@@ -12700,7 +12700,7 @@
           </a:bodyPr>
           <a:lstStyle/>
           <a:p>
-            <a:pPr algn="r"/>
+            <a:pPr algn="r" a:rtl="1"/>
             <a:r>
               <a:rPr sz="1300" b="0">
                 <a:solidFill>
@@ -12735,7 +12735,7 @@
           </a:bodyPr>
           <a:lstStyle/>
           <a:p>
-            <a:pPr algn="r"/>
+            <a:pPr algn="r" a:rtl="1"/>
             <a:r>
               <a:rPr sz="1300" b="0">
                 <a:solidFill>
@@ -12770,7 +12770,7 @@
           </a:bodyPr>
           <a:lstStyle/>
           <a:p>
-            <a:pPr algn="r"/>
+            <a:pPr algn="r" a:rtl="1"/>
             <a:r>
               <a:rPr sz="1300" b="0">
                 <a:solidFill>
@@ -12805,7 +12805,7 @@
           </a:bodyPr>
           <a:lstStyle/>
           <a:p>
-            <a:pPr algn="r"/>
+            <a:pPr algn="r" a:rtl="1"/>
             <a:r>
               <a:rPr sz="1300" b="0">
                 <a:solidFill>
@@ -12909,7 +12909,7 @@
           </a:bodyPr>
           <a:lstStyle/>
           <a:p>
-            <a:pPr algn="r"/>
+            <a:pPr algn="r" a:rtl="1"/>
             <a:r>
               <a:rPr sz="3600" b="1">
                 <a:solidFill>
@@ -13030,7 +13030,7 @@
           </a:bodyPr>
           <a:lstStyle/>
           <a:p>
-            <a:pPr algn="ctr"/>
+            <a:pPr algn="ctr" a:rtl="1"/>
             <a:r>
               <a:rPr sz="4000" b="1">
                 <a:solidFill>
@@ -13065,7 +13065,7 @@
           </a:bodyPr>
           <a:lstStyle/>
           <a:p>
-            <a:pPr algn="ctr"/>
+            <a:pPr algn="ctr" a:rtl="1"/>
             <a:r>
               <a:rPr sz="1400" b="0">
                 <a:solidFill>
@@ -13186,7 +13186,7 @@
           </a:bodyPr>
           <a:lstStyle/>
           <a:p>
-            <a:pPr algn="ctr"/>
+            <a:pPr algn="ctr" a:rtl="1"/>
             <a:r>
               <a:rPr sz="4000" b="1">
                 <a:solidFill>
@@ -13221,7 +13221,7 @@
           </a:bodyPr>
           <a:lstStyle/>
           <a:p>
-            <a:pPr algn="ctr"/>
+            <a:pPr algn="ctr" a:rtl="1"/>
             <a:r>
               <a:rPr sz="1400" b="0">
                 <a:solidFill>
@@ -13342,7 +13342,7 @@
           </a:bodyPr>
           <a:lstStyle/>
           <a:p>
-            <a:pPr algn="ctr"/>
+            <a:pPr algn="ctr" a:rtl="1"/>
             <a:r>
               <a:rPr sz="4000" b="1">
                 <a:solidFill>
@@ -13377,7 +13377,7 @@
           </a:bodyPr>
           <a:lstStyle/>
           <a:p>
-            <a:pPr algn="ctr"/>
+            <a:pPr algn="ctr" a:rtl="1"/>
             <a:r>
               <a:rPr sz="1400" b="0">
                 <a:solidFill>
@@ -13498,7 +13498,7 @@
           </a:bodyPr>
           <a:lstStyle/>
           <a:p>
-            <a:pPr algn="ctr"/>
+            <a:pPr algn="ctr" a:rtl="1"/>
             <a:r>
               <a:rPr sz="4000" b="1">
                 <a:solidFill>
@@ -13533,7 +13533,7 @@
           </a:bodyPr>
           <a:lstStyle/>
           <a:p>
-            <a:pPr algn="ctr"/>
+            <a:pPr algn="ctr" a:rtl="1"/>
             <a:r>
               <a:rPr sz="1400" b="0">
                 <a:solidFill>
@@ -13568,7 +13568,7 @@
           </a:bodyPr>
           <a:lstStyle/>
           <a:p>
-            <a:pPr algn="r"/>
+            <a:pPr algn="r" a:rtl="1"/>
             <a:r>
               <a:rPr sz="2000" b="1">
                 <a:solidFill>
@@ -13646,7 +13646,7 @@
           </a:bodyPr>
           <a:lstStyle/>
           <a:p>
-            <a:pPr algn="r"/>
+            <a:pPr algn="r" a:rtl="1"/>
             <a:r>
               <a:rPr sz="1400" b="1">
                 <a:solidFill>
@@ -13681,7 +13681,7 @@
           </a:bodyPr>
           <a:lstStyle/>
           <a:p>
-            <a:pPr algn="r"/>
+            <a:pPr algn="r" a:rtl="1"/>
             <a:r>
               <a:rPr sz="1300" b="0">
                 <a:solidFill>
@@ -13716,7 +13716,7 @@
           </a:bodyPr>
           <a:lstStyle/>
           <a:p>
-            <a:pPr algn="r"/>
+            <a:pPr algn="r" a:rtl="1"/>
             <a:r>
               <a:rPr sz="1000" b="0">
                 <a:solidFill>
@@ -13794,7 +13794,7 @@
           </a:bodyPr>
           <a:lstStyle/>
           <a:p>
-            <a:pPr algn="r"/>
+            <a:pPr algn="r" a:rtl="1"/>
             <a:r>
               <a:rPr sz="1400" b="1">
                 <a:solidFill>
@@ -13829,7 +13829,7 @@
           </a:bodyPr>
           <a:lstStyle/>
           <a:p>
-            <a:pPr algn="r"/>
+            <a:pPr algn="r" a:rtl="1"/>
             <a:r>
               <a:rPr sz="1300" b="0">
                 <a:solidFill>
@@ -13864,7 +13864,7 @@
           </a:bodyPr>
           <a:lstStyle/>
           <a:p>
-            <a:pPr algn="r"/>
+            <a:pPr algn="r" a:rtl="1"/>
             <a:r>
               <a:rPr sz="1000" b="0">
                 <a:solidFill>
@@ -13942,7 +13942,7 @@
           </a:bodyPr>
           <a:lstStyle/>
           <a:p>
-            <a:pPr algn="r"/>
+            <a:pPr algn="r" a:rtl="1"/>
             <a:r>
               <a:rPr sz="1400" b="1">
                 <a:solidFill>
@@ -13977,7 +13977,7 @@
           </a:bodyPr>
           <a:lstStyle/>
           <a:p>
-            <a:pPr algn="r"/>
+            <a:pPr algn="r" a:rtl="1"/>
             <a:r>
               <a:rPr sz="1300" b="0">
                 <a:solidFill>
@@ -14012,7 +14012,7 @@
           </a:bodyPr>
           <a:lstStyle/>
           <a:p>
-            <a:pPr algn="r"/>
+            <a:pPr algn="r" a:rtl="1"/>
             <a:r>
               <a:rPr sz="1000" b="0">
                 <a:solidFill>
@@ -14090,7 +14090,7 @@
           </a:bodyPr>
           <a:lstStyle/>
           <a:p>
-            <a:pPr algn="r"/>
+            <a:pPr algn="r" a:rtl="1"/>
             <a:r>
               <a:rPr sz="1400" b="1">
                 <a:solidFill>
@@ -14125,7 +14125,7 @@
           </a:bodyPr>
           <a:lstStyle/>
           <a:p>
-            <a:pPr algn="r"/>
+            <a:pPr algn="r" a:rtl="1"/>
             <a:r>
               <a:rPr sz="1300" b="0">
                 <a:solidFill>
@@ -14160,7 +14160,7 @@
           </a:bodyPr>
           <a:lstStyle/>
           <a:p>
-            <a:pPr algn="r"/>
+            <a:pPr algn="r" a:rtl="1"/>
             <a:r>
               <a:rPr sz="1000" b="0">
                 <a:solidFill>
@@ -14195,7 +14195,7 @@
           </a:bodyPr>
           <a:lstStyle/>
           <a:p>
-            <a:pPr algn="r"/>
+            <a:pPr algn="r" a:rtl="1"/>
             <a:r>
               <a:rPr sz="2000" b="1">
                 <a:solidFill>
@@ -14273,7 +14273,7 @@
           </a:bodyPr>
           <a:lstStyle/>
           <a:p>
-            <a:pPr algn="ctr"/>
+            <a:pPr algn="ctr" a:rtl="1"/>
             <a:r>
               <a:rPr sz="1400" b="1">
                 <a:solidFill>
@@ -14308,7 +14308,7 @@
           </a:bodyPr>
           <a:lstStyle/>
           <a:p>
-            <a:pPr algn="ctr"/>
+            <a:pPr algn="ctr" a:rtl="1"/>
             <a:r>
               <a:rPr sz="1400" b="1">
                 <a:solidFill>
@@ -14343,7 +14343,7 @@
           </a:bodyPr>
           <a:lstStyle/>
           <a:p>
-            <a:pPr algn="ctr"/>
+            <a:pPr algn="ctr" a:rtl="1"/>
             <a:r>
               <a:rPr sz="1400" b="1">
                 <a:solidFill>
@@ -14421,7 +14421,7 @@
           </a:bodyPr>
           <a:lstStyle/>
           <a:p>
-            <a:pPr algn="ctr"/>
+            <a:pPr algn="ctr" a:rtl="1"/>
             <a:r>
               <a:rPr sz="1200" b="0">
                 <a:solidFill>
@@ -14456,7 +14456,7 @@
           </a:bodyPr>
           <a:lstStyle/>
           <a:p>
-            <a:pPr algn="ctr"/>
+            <a:pPr algn="ctr" a:rtl="1"/>
             <a:r>
               <a:rPr sz="1200" b="1">
                 <a:solidFill>
@@ -14491,7 +14491,7 @@
           </a:bodyPr>
           <a:lstStyle/>
           <a:p>
-            <a:pPr algn="ctr"/>
+            <a:pPr algn="ctr" a:rtl="1"/>
             <a:r>
               <a:rPr sz="1200" b="0">
                 <a:solidFill>
@@ -14569,7 +14569,7 @@
           </a:bodyPr>
           <a:lstStyle/>
           <a:p>
-            <a:pPr algn="ctr"/>
+            <a:pPr algn="ctr" a:rtl="1"/>
             <a:r>
               <a:rPr sz="1200" b="0">
                 <a:solidFill>
@@ -14604,7 +14604,7 @@
           </a:bodyPr>
           <a:lstStyle/>
           <a:p>
-            <a:pPr algn="ctr"/>
+            <a:pPr algn="ctr" a:rtl="1"/>
             <a:r>
               <a:rPr sz="1200" b="1">
                 <a:solidFill>
@@ -14639,7 +14639,7 @@
           </a:bodyPr>
           <a:lstStyle/>
           <a:p>
-            <a:pPr algn="ctr"/>
+            <a:pPr algn="ctr" a:rtl="1"/>
             <a:r>
               <a:rPr sz="1200" b="0">
                 <a:solidFill>
@@ -14717,7 +14717,7 @@
           </a:bodyPr>
           <a:lstStyle/>
           <a:p>
-            <a:pPr algn="ctr"/>
+            <a:pPr algn="ctr" a:rtl="1"/>
             <a:r>
               <a:rPr sz="1200" b="0">
                 <a:solidFill>
@@ -14752,7 +14752,7 @@
           </a:bodyPr>
           <a:lstStyle/>
           <a:p>
-            <a:pPr algn="ctr"/>
+            <a:pPr algn="ctr" a:rtl="1"/>
             <a:r>
               <a:rPr sz="1200" b="1">
                 <a:solidFill>
@@ -14787,7 +14787,7 @@
           </a:bodyPr>
           <a:lstStyle/>
           <a:p>
-            <a:pPr algn="ctr"/>
+            <a:pPr algn="ctr" a:rtl="1"/>
             <a:r>
               <a:rPr sz="1200" b="0">
                 <a:solidFill>
@@ -14865,7 +14865,7 @@
           </a:bodyPr>
           <a:lstStyle/>
           <a:p>
-            <a:pPr algn="ctr"/>
+            <a:pPr algn="ctr" a:rtl="1"/>
             <a:r>
               <a:rPr sz="1200" b="0">
                 <a:solidFill>
@@ -14900,7 +14900,7 @@
           </a:bodyPr>
           <a:lstStyle/>
           <a:p>
-            <a:pPr algn="ctr"/>
+            <a:pPr algn="ctr" a:rtl="1"/>
             <a:r>
               <a:rPr sz="1200" b="1">
                 <a:solidFill>
@@ -14935,7 +14935,7 @@
           </a:bodyPr>
           <a:lstStyle/>
           <a:p>
-            <a:pPr algn="ctr"/>
+            <a:pPr algn="ctr" a:rtl="1"/>
             <a:r>
               <a:rPr sz="1200" b="0">
                 <a:solidFill>
@@ -14996,7 +14996,7 @@
           </a:bodyPr>
           <a:lstStyle/>
           <a:p>
-            <a:pPr algn="r"/>
+            <a:pPr algn="r" a:rtl="1"/>
             <a:r>
               <a:rPr sz="3600" b="1">
                 <a:solidFill>
@@ -15117,7 +15117,7 @@
           </a:bodyPr>
           <a:lstStyle/>
           <a:p>
-            <a:pPr algn="r"/>
+            <a:pPr algn="r" a:rtl="1"/>
             <a:r>
               <a:rPr sz="1600" b="1">
                 <a:solidFill>
@@ -15152,7 +15152,7 @@
           </a:bodyPr>
           <a:lstStyle/>
           <a:p>
-            <a:pPr algn="r"/>
+            <a:pPr algn="r" a:rtl="1"/>
             <a:r>
               <a:rPr sz="1200" b="0">
                 <a:solidFill>
@@ -15187,7 +15187,7 @@
           </a:bodyPr>
           <a:lstStyle/>
           <a:p>
-            <a:pPr algn="r"/>
+            <a:pPr algn="r" a:rtl="1"/>
             <a:r>
               <a:rPr sz="1200" b="0">
                 <a:solidFill>
@@ -15222,7 +15222,7 @@
           </a:bodyPr>
           <a:lstStyle/>
           <a:p>
-            <a:pPr algn="r"/>
+            <a:pPr algn="r" a:rtl="1"/>
             <a:r>
               <a:rPr sz="1200" b="0">
                 <a:solidFill>
@@ -15343,7 +15343,7 @@
           </a:bodyPr>
           <a:lstStyle/>
           <a:p>
-            <a:pPr algn="r"/>
+            <a:pPr algn="r" a:rtl="1"/>
             <a:r>
               <a:rPr sz="1600" b="1">
                 <a:solidFill>
@@ -15378,7 +15378,7 @@
           </a:bodyPr>
           <a:lstStyle/>
           <a:p>
-            <a:pPr algn="r"/>
+            <a:pPr algn="r" a:rtl="1"/>
             <a:r>
               <a:rPr sz="1200" b="0">
                 <a:solidFill>
@@ -15413,7 +15413,7 @@
           </a:bodyPr>
           <a:lstStyle/>
           <a:p>
-            <a:pPr algn="r"/>
+            <a:pPr algn="r" a:rtl="1"/>
             <a:r>
               <a:rPr sz="1200" b="0">
                 <a:solidFill>
@@ -15448,7 +15448,7 @@
           </a:bodyPr>
           <a:lstStyle/>
           <a:p>
-            <a:pPr algn="r"/>
+            <a:pPr algn="r" a:rtl="1"/>
             <a:r>
               <a:rPr sz="1200" b="0">
                 <a:solidFill>
@@ -15569,7 +15569,7 @@
           </a:bodyPr>
           <a:lstStyle/>
           <a:p>
-            <a:pPr algn="r"/>
+            <a:pPr algn="r" a:rtl="1"/>
             <a:r>
               <a:rPr sz="1600" b="1">
                 <a:solidFill>
@@ -15604,7 +15604,7 @@
           </a:bodyPr>
           <a:lstStyle/>
           <a:p>
-            <a:pPr algn="r"/>
+            <a:pPr algn="r" a:rtl="1"/>
             <a:r>
               <a:rPr sz="1200" b="0">
                 <a:solidFill>
@@ -15639,7 +15639,7 @@
           </a:bodyPr>
           <a:lstStyle/>
           <a:p>
-            <a:pPr algn="r"/>
+            <a:pPr algn="r" a:rtl="1"/>
             <a:r>
               <a:rPr sz="1200" b="0">
                 <a:solidFill>
@@ -15674,7 +15674,7 @@
           </a:bodyPr>
           <a:lstStyle/>
           <a:p>
-            <a:pPr algn="r"/>
+            <a:pPr algn="r" a:rtl="1"/>
             <a:r>
               <a:rPr sz="1200" b="0">
                 <a:solidFill>
@@ -15795,7 +15795,7 @@
           </a:bodyPr>
           <a:lstStyle/>
           <a:p>
-            <a:pPr algn="r"/>
+            <a:pPr algn="r" a:rtl="1"/>
             <a:r>
               <a:rPr sz="1600" b="1">
                 <a:solidFill>
@@ -15830,7 +15830,7 @@
           </a:bodyPr>
           <a:lstStyle/>
           <a:p>
-            <a:pPr algn="r"/>
+            <a:pPr algn="r" a:rtl="1"/>
             <a:r>
               <a:rPr sz="1200" b="0">
                 <a:solidFill>
@@ -15865,7 +15865,7 @@
           </a:bodyPr>
           <a:lstStyle/>
           <a:p>
-            <a:pPr algn="r"/>
+            <a:pPr algn="r" a:rtl="1"/>
             <a:r>
               <a:rPr sz="1200" b="0">
                 <a:solidFill>
@@ -15900,7 +15900,7 @@
           </a:bodyPr>
           <a:lstStyle/>
           <a:p>
-            <a:pPr algn="r"/>
+            <a:pPr algn="r" a:rtl="1"/>
             <a:r>
               <a:rPr sz="1200" b="0">
                 <a:solidFill>
@@ -16021,7 +16021,7 @@
           </a:bodyPr>
           <a:lstStyle/>
           <a:p>
-            <a:pPr algn="r"/>
+            <a:pPr algn="r" a:rtl="1"/>
             <a:r>
               <a:rPr sz="1600" b="1">
                 <a:solidFill>
@@ -16056,7 +16056,7 @@
           </a:bodyPr>
           <a:lstStyle/>
           <a:p>
-            <a:pPr algn="r"/>
+            <a:pPr algn="r" a:rtl="1"/>
             <a:r>
               <a:rPr sz="1200" b="0">
                 <a:solidFill>
@@ -16091,7 +16091,7 @@
           </a:bodyPr>
           <a:lstStyle/>
           <a:p>
-            <a:pPr algn="r"/>
+            <a:pPr algn="r" a:rtl="1"/>
             <a:r>
               <a:rPr sz="1200" b="0">
                 <a:solidFill>
@@ -16126,7 +16126,7 @@
           </a:bodyPr>
           <a:lstStyle/>
           <a:p>
-            <a:pPr algn="r"/>
+            <a:pPr algn="r" a:rtl="1"/>
             <a:r>
               <a:rPr sz="1200" b="0">
                 <a:solidFill>
@@ -16247,7 +16247,7 @@
           </a:bodyPr>
           <a:lstStyle/>
           <a:p>
-            <a:pPr algn="r"/>
+            <a:pPr algn="r" a:rtl="1"/>
             <a:r>
               <a:rPr sz="1600" b="1">
                 <a:solidFill>
@@ -16282,7 +16282,7 @@
           </a:bodyPr>
           <a:lstStyle/>
           <a:p>
-            <a:pPr algn="r"/>
+            <a:pPr algn="r" a:rtl="1"/>
             <a:r>
               <a:rPr sz="1200" b="0">
                 <a:solidFill>
@@ -16317,7 +16317,7 @@
           </a:bodyPr>
           <a:lstStyle/>
           <a:p>
-            <a:pPr algn="r"/>
+            <a:pPr algn="r" a:rtl="1"/>
             <a:r>
               <a:rPr sz="1200" b="0">
                 <a:solidFill>
@@ -16352,7 +16352,7 @@
           </a:bodyPr>
           <a:lstStyle/>
           <a:p>
-            <a:pPr algn="r"/>
+            <a:pPr algn="r" a:rtl="1"/>
             <a:r>
               <a:rPr sz="1200" b="0">
                 <a:solidFill>
@@ -16430,7 +16430,7 @@
           </a:bodyPr>
           <a:lstStyle/>
           <a:p>
-            <a:pPr algn="ctr"/>
+            <a:pPr algn="ctr" a:rtl="1"/>
             <a:r>
               <a:rPr sz="1400" b="0">
                 <a:solidFill>
@@ -16534,7 +16534,7 @@
           </a:bodyPr>
           <a:lstStyle/>
           <a:p>
-            <a:pPr algn="r"/>
+            <a:pPr algn="r" a:rtl="1"/>
             <a:r>
               <a:rPr sz="3600" b="1">
                 <a:solidFill>
@@ -16569,7 +16569,7 @@
           </a:bodyPr>
           <a:lstStyle/>
           <a:p>
-            <a:pPr algn="r"/>
+            <a:pPr algn="r" a:rtl="1"/>
             <a:r>
               <a:rPr sz="2000" b="1">
                 <a:solidFill>
@@ -16690,7 +16690,7 @@
           </a:bodyPr>
           <a:lstStyle/>
           <a:p>
-            <a:pPr algn="r"/>
+            <a:pPr algn="r" a:rtl="1"/>
             <a:r>
               <a:rPr sz="1300" b="0">
                 <a:solidFill>
@@ -16725,7 +16725,7 @@
           </a:bodyPr>
           <a:lstStyle/>
           <a:p>
-            <a:pPr algn="r"/>
+            <a:pPr algn="r" a:rtl="1"/>
             <a:r>
               <a:rPr sz="1300" b="1">
                 <a:solidFill>
@@ -16760,7 +16760,7 @@
           </a:bodyPr>
           <a:lstStyle/>
           <a:p>
-            <a:pPr algn="r"/>
+            <a:pPr algn="r" a:rtl="1"/>
             <a:r>
               <a:rPr sz="1100" b="0">
                 <a:solidFill>
@@ -16881,7 +16881,7 @@
           </a:bodyPr>
           <a:lstStyle/>
           <a:p>
-            <a:pPr algn="r"/>
+            <a:pPr algn="r" a:rtl="1"/>
             <a:r>
               <a:rPr sz="1300" b="0">
                 <a:solidFill>
@@ -16916,7 +16916,7 @@
           </a:bodyPr>
           <a:lstStyle/>
           <a:p>
-            <a:pPr algn="r"/>
+            <a:pPr algn="r" a:rtl="1"/>
             <a:r>
               <a:rPr sz="1300" b="1">
                 <a:solidFill>
@@ -16951,7 +16951,7 @@
           </a:bodyPr>
           <a:lstStyle/>
           <a:p>
-            <a:pPr algn="r"/>
+            <a:pPr algn="r" a:rtl="1"/>
             <a:r>
               <a:rPr sz="1100" b="0">
                 <a:solidFill>
@@ -17072,7 +17072,7 @@
           </a:bodyPr>
           <a:lstStyle/>
           <a:p>
-            <a:pPr algn="r"/>
+            <a:pPr algn="r" a:rtl="1"/>
             <a:r>
               <a:rPr sz="1300" b="0">
                 <a:solidFill>
@@ -17107,7 +17107,7 @@
           </a:bodyPr>
           <a:lstStyle/>
           <a:p>
-            <a:pPr algn="r"/>
+            <a:pPr algn="r" a:rtl="1"/>
             <a:r>
               <a:rPr sz="1300" b="1">
                 <a:solidFill>
@@ -17142,7 +17142,7 @@
           </a:bodyPr>
           <a:lstStyle/>
           <a:p>
-            <a:pPr algn="r"/>
+            <a:pPr algn="r" a:rtl="1"/>
             <a:r>
               <a:rPr sz="1100" b="0">
                 <a:solidFill>
@@ -17263,7 +17263,7 @@
           </a:bodyPr>
           <a:lstStyle/>
           <a:p>
-            <a:pPr algn="r"/>
+            <a:pPr algn="r" a:rtl="1"/>
             <a:r>
               <a:rPr sz="1300" b="0">
                 <a:solidFill>
@@ -17298,7 +17298,7 @@
           </a:bodyPr>
           <a:lstStyle/>
           <a:p>
-            <a:pPr algn="r"/>
+            <a:pPr algn="r" a:rtl="1"/>
             <a:r>
               <a:rPr sz="1300" b="1">
                 <a:solidFill>
@@ -17333,7 +17333,7 @@
           </a:bodyPr>
           <a:lstStyle/>
           <a:p>
-            <a:pPr algn="r"/>
+            <a:pPr algn="r" a:rtl="1"/>
             <a:r>
               <a:rPr sz="1100" b="0">
                 <a:solidFill>
@@ -17454,7 +17454,7 @@
           </a:bodyPr>
           <a:lstStyle/>
           <a:p>
-            <a:pPr algn="r"/>
+            <a:pPr algn="r" a:rtl="1"/>
             <a:r>
               <a:rPr sz="1300" b="0">
                 <a:solidFill>
@@ -17489,7 +17489,7 @@
           </a:bodyPr>
           <a:lstStyle/>
           <a:p>
-            <a:pPr algn="r"/>
+            <a:pPr algn="r" a:rtl="1"/>
             <a:r>
               <a:rPr sz="1300" b="1">
                 <a:solidFill>
@@ -17524,7 +17524,7 @@
           </a:bodyPr>
           <a:lstStyle/>
           <a:p>
-            <a:pPr algn="r"/>
+            <a:pPr algn="r" a:rtl="1"/>
             <a:r>
               <a:rPr sz="1100" b="0">
                 <a:solidFill>
@@ -17645,7 +17645,7 @@
           </a:bodyPr>
           <a:lstStyle/>
           <a:p>
-            <a:pPr algn="r"/>
+            <a:pPr algn="r" a:rtl="1"/>
             <a:r>
               <a:rPr sz="1300" b="0">
                 <a:solidFill>
@@ -17680,7 +17680,7 @@
           </a:bodyPr>
           <a:lstStyle/>
           <a:p>
-            <a:pPr algn="r"/>
+            <a:pPr algn="r" a:rtl="1"/>
             <a:r>
               <a:rPr sz="1300" b="1">
                 <a:solidFill>
@@ -17715,7 +17715,7 @@
           </a:bodyPr>
           <a:lstStyle/>
           <a:p>
-            <a:pPr algn="r"/>
+            <a:pPr algn="r" a:rtl="1"/>
             <a:r>
               <a:rPr sz="1100" b="0">
                 <a:solidFill>
@@ -17793,7 +17793,7 @@
           </a:bodyPr>
           <a:lstStyle/>
           <a:p>
-            <a:pPr algn="r"/>
+            <a:pPr algn="r" a:rtl="1"/>
             <a:r>
               <a:rPr sz="1400" b="1">
                 <a:solidFill>
@@ -17828,7 +17828,7 @@
           </a:bodyPr>
           <a:lstStyle/>
           <a:p>
-            <a:pPr algn="r"/>
+            <a:pPr algn="r" a:rtl="1"/>
             <a:r>
               <a:rPr sz="1400" b="1">
                 <a:solidFill>
@@ -17949,7 +17949,7 @@
           </a:bodyPr>
           <a:lstStyle/>
           <a:p>
-            <a:pPr algn="r"/>
+            <a:pPr algn="r" a:rtl="1"/>
             <a:r>
               <a:rPr sz="2400" b="1">
                 <a:solidFill>
@@ -17984,7 +17984,7 @@
           </a:bodyPr>
           <a:lstStyle/>
           <a:p>
-            <a:pPr algn="ctr"/>
+            <a:pPr algn="ctr" a:rtl="1"/>
             <a:r>
               <a:rPr sz="5600" b="1">
                 <a:solidFill>
@@ -18019,7 +18019,7 @@
           </a:bodyPr>
           <a:lstStyle/>
           <a:p>
-            <a:pPr algn="ctr"/>
+            <a:pPr algn="ctr" a:rtl="1"/>
             <a:r>
               <a:rPr sz="1600" b="0">
                 <a:solidFill>
@@ -18054,7 +18054,7 @@
           </a:bodyPr>
           <a:lstStyle/>
           <a:p>
-            <a:pPr algn="ctr">
+            <a:pPr algn="ctr" a:rtl="1">
               <a:spcAft>
                 <a:spcPts val="560"/>
               </a:spcAft>
@@ -18070,7 +18070,7 @@
             </a:r>
           </a:p>
           <a:p>
-            <a:pPr algn="ctr">
+            <a:pPr algn="ctr" a:rtl="1">
               <a:spcAft>
                 <a:spcPts val="560"/>
               </a:spcAft>
@@ -18086,7 +18086,7 @@
             </a:r>
           </a:p>
           <a:p>
-            <a:pPr algn="ctr">
+            <a:pPr algn="ctr" a:rtl="1">
               <a:spcAft>
                 <a:spcPts val="560"/>
               </a:spcAft>
@@ -18102,7 +18102,7 @@
             </a:r>
           </a:p>
           <a:p>
-            <a:pPr algn="ctr">
+            <a:pPr algn="ctr" a:rtl="1">
               <a:spcAft>
                 <a:spcPts val="560"/>
               </a:spcAft>
@@ -18118,7 +18118,7 @@
             </a:r>
           </a:p>
           <a:p>
-            <a:pPr algn="ctr">
+            <a:pPr algn="ctr" a:rtl="1">
               <a:spcAft>
                 <a:spcPts val="560"/>
               </a:spcAft>
@@ -18134,7 +18134,7 @@
             </a:r>
           </a:p>
           <a:p>
-            <a:pPr algn="ctr">
+            <a:pPr algn="ctr" a:rtl="1">
               <a:spcAft>
                 <a:spcPts val="560"/>
               </a:spcAft>

</xml_diff>